<commit_message>
before creating the submission copy
</commit_message>
<xml_diff>
--- a/paper_plots/ppt13_concept_and_flowchart.pptx
+++ b/paper_plots/ppt13_concept_and_flowchart.pptx
@@ -243,7 +243,7 @@
           <a:p>
             <a:fld id="{EC25FAA8-77F2-5C42-A9DC-2A9BDE3DA24F}" type="datetimeFigureOut">
               <a:rPr lang="en-US" smtClean="0"/>
-              <a:t>9/11/25</a:t>
+              <a:t>10/9/25</a:t>
             </a:fld>
             <a:endParaRPr lang="en-US"/>
           </a:p>
@@ -413,7 +413,7 @@
           <a:p>
             <a:fld id="{EC25FAA8-77F2-5C42-A9DC-2A9BDE3DA24F}" type="datetimeFigureOut">
               <a:rPr lang="en-US" smtClean="0"/>
-              <a:t>9/11/25</a:t>
+              <a:t>10/9/25</a:t>
             </a:fld>
             <a:endParaRPr lang="en-US"/>
           </a:p>
@@ -593,7 +593,7 @@
           <a:p>
             <a:fld id="{EC25FAA8-77F2-5C42-A9DC-2A9BDE3DA24F}" type="datetimeFigureOut">
               <a:rPr lang="en-US" smtClean="0"/>
-              <a:t>9/11/25</a:t>
+              <a:t>10/9/25</a:t>
             </a:fld>
             <a:endParaRPr lang="en-US"/>
           </a:p>
@@ -763,7 +763,7 @@
           <a:p>
             <a:fld id="{EC25FAA8-77F2-5C42-A9DC-2A9BDE3DA24F}" type="datetimeFigureOut">
               <a:rPr lang="en-US" smtClean="0"/>
-              <a:t>9/11/25</a:t>
+              <a:t>10/9/25</a:t>
             </a:fld>
             <a:endParaRPr lang="en-US"/>
           </a:p>
@@ -1009,7 +1009,7 @@
           <a:p>
             <a:fld id="{EC25FAA8-77F2-5C42-A9DC-2A9BDE3DA24F}" type="datetimeFigureOut">
               <a:rPr lang="en-US" smtClean="0"/>
-              <a:t>9/11/25</a:t>
+              <a:t>10/9/25</a:t>
             </a:fld>
             <a:endParaRPr lang="en-US"/>
           </a:p>
@@ -1241,7 +1241,7 @@
           <a:p>
             <a:fld id="{EC25FAA8-77F2-5C42-A9DC-2A9BDE3DA24F}" type="datetimeFigureOut">
               <a:rPr lang="en-US" smtClean="0"/>
-              <a:t>9/11/25</a:t>
+              <a:t>10/9/25</a:t>
             </a:fld>
             <a:endParaRPr lang="en-US"/>
           </a:p>
@@ -1608,7 +1608,7 @@
           <a:p>
             <a:fld id="{EC25FAA8-77F2-5C42-A9DC-2A9BDE3DA24F}" type="datetimeFigureOut">
               <a:rPr lang="en-US" smtClean="0"/>
-              <a:t>9/11/25</a:t>
+              <a:t>10/9/25</a:t>
             </a:fld>
             <a:endParaRPr lang="en-US"/>
           </a:p>
@@ -1726,7 +1726,7 @@
           <a:p>
             <a:fld id="{EC25FAA8-77F2-5C42-A9DC-2A9BDE3DA24F}" type="datetimeFigureOut">
               <a:rPr lang="en-US" smtClean="0"/>
-              <a:t>9/11/25</a:t>
+              <a:t>10/9/25</a:t>
             </a:fld>
             <a:endParaRPr lang="en-US"/>
           </a:p>
@@ -1821,7 +1821,7 @@
           <a:p>
             <a:fld id="{EC25FAA8-77F2-5C42-A9DC-2A9BDE3DA24F}" type="datetimeFigureOut">
               <a:rPr lang="en-US" smtClean="0"/>
-              <a:t>9/11/25</a:t>
+              <a:t>10/9/25</a:t>
             </a:fld>
             <a:endParaRPr lang="en-US"/>
           </a:p>
@@ -2098,7 +2098,7 @@
           <a:p>
             <a:fld id="{EC25FAA8-77F2-5C42-A9DC-2A9BDE3DA24F}" type="datetimeFigureOut">
               <a:rPr lang="en-US" smtClean="0"/>
-              <a:t>9/11/25</a:t>
+              <a:t>10/9/25</a:t>
             </a:fld>
             <a:endParaRPr lang="en-US"/>
           </a:p>
@@ -2355,7 +2355,7 @@
           <a:p>
             <a:fld id="{EC25FAA8-77F2-5C42-A9DC-2A9BDE3DA24F}" type="datetimeFigureOut">
               <a:rPr lang="en-US" smtClean="0"/>
-              <a:t>9/11/25</a:t>
+              <a:t>10/9/25</a:t>
             </a:fld>
             <a:endParaRPr lang="en-US"/>
           </a:p>
@@ -2568,7 +2568,7 @@
           <a:p>
             <a:fld id="{EC25FAA8-77F2-5C42-A9DC-2A9BDE3DA24F}" type="datetimeFigureOut">
               <a:rPr lang="en-US" smtClean="0"/>
-              <a:t>9/11/25</a:t>
+              <a:t>10/9/25</a:t>
             </a:fld>
             <a:endParaRPr lang="en-US"/>
           </a:p>
@@ -5113,8 +5113,8 @@
           </p:nvSpPr>
           <p:spPr>
             <a:xfrm>
-              <a:off x="1742883" y="3035600"/>
-              <a:ext cx="811412" cy="277996"/>
+              <a:off x="1742883" y="3053415"/>
+              <a:ext cx="811412" cy="262112"/>
             </a:xfrm>
             <a:prstGeom prst="rect">
               <a:avLst/>
@@ -5135,7 +5135,7 @@
                     <a:srgbClr val="457499"/>
                   </a:solidFill>
                 </a:rPr>
-                <a:t>Pert.1</a:t>
+                <a:t>Pert1</a:t>
               </a:r>
             </a:p>
           </p:txBody>
@@ -5155,9 +5155,9 @@
           <p:grpSpPr>
             <a:xfrm>
               <a:off x="1327435" y="1468457"/>
-              <a:ext cx="7000899" cy="718721"/>
+              <a:ext cx="7000899" cy="679011"/>
               <a:chOff x="1320220" y="1457169"/>
-              <a:chExt cx="7000899" cy="718721"/>
+              <a:chExt cx="7000899" cy="679011"/>
             </a:xfrm>
           </p:grpSpPr>
           <p:sp>
@@ -5175,7 +5175,7 @@
             <p:spPr>
               <a:xfrm>
                 <a:off x="1320220" y="1468180"/>
-                <a:ext cx="1716522" cy="694990"/>
+                <a:ext cx="1716522" cy="655280"/>
               </a:xfrm>
               <a:prstGeom prst="rect">
                 <a:avLst/>
@@ -5214,7 +5214,7 @@
                       <a:srgbClr val="457499"/>
                     </a:solidFill>
                   </a:rPr>
-                  <a:t>Pert.1 vs. Control </a:t>
+                  <a:t>Pert1 vs. Control </a:t>
                 </a:r>
               </a:p>
             </p:txBody>
@@ -5234,7 +5234,7 @@
             <p:spPr>
               <a:xfrm>
                 <a:off x="3808757" y="1480900"/>
-                <a:ext cx="2075312" cy="694990"/>
+                <a:ext cx="2075312" cy="655280"/>
               </a:xfrm>
               <a:prstGeom prst="rect">
                 <a:avLst/>
@@ -5266,7 +5266,7 @@
                       <a:srgbClr val="457499"/>
                     </a:solidFill>
                   </a:rPr>
-                  <a:t>Pert.2 vs. Control</a:t>
+                  <a:t>Pert2 vs. Control</a:t>
                 </a:r>
               </a:p>
             </p:txBody>
@@ -5286,7 +5286,7 @@
             <p:spPr>
               <a:xfrm>
                 <a:off x="6472486" y="1457169"/>
-                <a:ext cx="1848633" cy="694990"/>
+                <a:ext cx="1848633" cy="655281"/>
               </a:xfrm>
               <a:prstGeom prst="rect">
                 <a:avLst/>
@@ -5311,7 +5311,7 @@
                       <a:srgbClr val="6D3991"/>
                     </a:solidFill>
                   </a:rPr>
-                  <a:t>Pert.2 vs. Control </a:t>
+                  <a:t>Pert2 vs. Control </a:t>
                 </a:r>
               </a:p>
             </p:txBody>
@@ -5331,10 +5331,10 @@
           </p:nvGrpSpPr>
           <p:grpSpPr>
             <a:xfrm>
-              <a:off x="1133045" y="1225264"/>
-              <a:ext cx="7340567" cy="1215483"/>
-              <a:chOff x="1133045" y="1225264"/>
-              <a:chExt cx="7340567" cy="1215483"/>
+              <a:off x="1133046" y="1225264"/>
+              <a:ext cx="7340566" cy="1215483"/>
+              <a:chOff x="1133046" y="1225264"/>
+              <a:chExt cx="7340566" cy="1215483"/>
             </a:xfrm>
           </p:grpSpPr>
           <p:sp>
@@ -5351,8 +5351,8 @@
             </p:nvSpPr>
             <p:spPr>
               <a:xfrm>
-                <a:off x="1133045" y="1225264"/>
-                <a:ext cx="2241397" cy="1215483"/>
+                <a:off x="1133046" y="1225264"/>
+                <a:ext cx="2016687" cy="1215483"/>
               </a:xfrm>
               <a:prstGeom prst="roundRect">
                 <a:avLst/>
@@ -5408,7 +5408,7 @@
             <p:spPr>
               <a:xfrm>
                 <a:off x="3682630" y="1225264"/>
-                <a:ext cx="2241397" cy="1215483"/>
+                <a:ext cx="2016687" cy="1215483"/>
               </a:xfrm>
               <a:prstGeom prst="roundRect">
                 <a:avLst/>
@@ -5738,8 +5738,8 @@
           </p:nvSpPr>
           <p:spPr>
             <a:xfrm>
-              <a:off x="3410928" y="1753112"/>
-              <a:ext cx="214949" cy="115776"/>
+              <a:off x="3238346" y="1776409"/>
+              <a:ext cx="387531" cy="92479"/>
             </a:xfrm>
             <a:prstGeom prst="rightArrow">
               <a:avLst/>
@@ -5787,8 +5787,8 @@
           </p:nvSpPr>
           <p:spPr>
             <a:xfrm>
-              <a:off x="5988525" y="1753112"/>
-              <a:ext cx="214949" cy="115776"/>
+              <a:off x="5796254" y="1773909"/>
+              <a:ext cx="370814" cy="94979"/>
             </a:xfrm>
             <a:prstGeom prst="rightArrow">
               <a:avLst/>
@@ -6027,7 +6027,7 @@
         <p:spPr>
           <a:xfrm>
             <a:off x="9233267" y="10673466"/>
-            <a:ext cx="850362" cy="369332"/>
+            <a:ext cx="734945" cy="369332"/>
           </a:xfrm>
           <a:prstGeom prst="rect">
             <a:avLst/>
@@ -6048,7 +6048,7 @@
                   <a:srgbClr val="6D3991"/>
                 </a:solidFill>
               </a:rPr>
-              <a:t>Pert. 2</a:t>
+              <a:t>Pert2</a:t>
             </a:r>
             <a:endParaRPr lang="en-US" sz="2000" b="1" dirty="0">
               <a:solidFill>
@@ -6129,7 +6129,7 @@
                   <a:srgbClr val="457499"/>
                 </a:solidFill>
               </a:rPr>
-              <a:t>Pert. 2</a:t>
+              <a:t>Pert2</a:t>
             </a:r>
             <a:endParaRPr lang="en-US" sz="2000" b="1" dirty="0">
               <a:solidFill>
@@ -6139,6 +6139,66 @@
           </a:p>
         </p:txBody>
       </p:sp>
+      <p:pic>
+        <p:nvPicPr>
+          <p:cNvPr id="83" name="Picture 82">
+            <a:extLst>
+              <a:ext uri="{FF2B5EF4-FFF2-40B4-BE49-F238E27FC236}">
+                <a16:creationId xmlns:a16="http://schemas.microsoft.com/office/drawing/2014/main" id="{3B5D6764-1343-8E38-28F6-DAEFE3B0C031}"/>
+              </a:ext>
+            </a:extLst>
+          </p:cNvPr>
+          <p:cNvPicPr>
+            <a:picLocks noChangeAspect="1"/>
+          </p:cNvPicPr>
+          <p:nvPr/>
+        </p:nvPicPr>
+        <p:blipFill>
+          <a:blip r:embed="rId16"/>
+          <a:stretch>
+            <a:fillRect/>
+          </a:stretch>
+        </p:blipFill>
+        <p:spPr>
+          <a:xfrm>
+            <a:off x="4470963" y="7899333"/>
+            <a:ext cx="241300" cy="203200"/>
+          </a:xfrm>
+          <a:prstGeom prst="rect">
+            <a:avLst/>
+          </a:prstGeom>
+        </p:spPr>
+      </p:pic>
+      <p:pic>
+        <p:nvPicPr>
+          <p:cNvPr id="84" name="Picture 83">
+            <a:extLst>
+              <a:ext uri="{FF2B5EF4-FFF2-40B4-BE49-F238E27FC236}">
+                <a16:creationId xmlns:a16="http://schemas.microsoft.com/office/drawing/2014/main" id="{9CEC33CF-EABD-6853-4A66-06614E5D5032}"/>
+              </a:ext>
+            </a:extLst>
+          </p:cNvPr>
+          <p:cNvPicPr>
+            <a:picLocks noChangeAspect="1"/>
+          </p:cNvPicPr>
+          <p:nvPr/>
+        </p:nvPicPr>
+        <p:blipFill>
+          <a:blip r:embed="rId17"/>
+          <a:stretch>
+            <a:fillRect/>
+          </a:stretch>
+        </p:blipFill>
+        <p:spPr>
+          <a:xfrm>
+            <a:off x="7889766" y="7931302"/>
+            <a:ext cx="241300" cy="203200"/>
+          </a:xfrm>
+          <a:prstGeom prst="rect">
+            <a:avLst/>
+          </a:prstGeom>
+        </p:spPr>
+      </p:pic>
     </p:spTree>
     <p:extLst>
       <p:ext uri="{BB962C8B-B14F-4D97-AF65-F5344CB8AC3E}">

</xml_diff>